<commit_message>
Update the Neoply presentation
Co-Authored-By: Claude Sonnet 5 <noreply@anthropic.com>
</commit_message>
<xml_diff>
--- a/docs/public/Neoply.pptx
+++ b/docs/public/Neoply.pptx
@@ -137,381 +137,59 @@
 </p:presentation>
 </file>
 
-<file path=ppt/revisionInfo.xml><?xml version="1.0" encoding="utf-8"?>
-<p1510:revInfo xmlns:a="http://schemas.openxmlformats.org/drawingml/2006/main" xmlns:r="http://schemas.openxmlformats.org/officeDocument/2006/relationships" xmlns:p1510="http://schemas.microsoft.com/office/powerpoint/2015/10/main">
-  <p1510:revLst>
-    <p1510:client id="{D4B8EA8B-463A-4099-A722-AFAD362EE1C0}" v="261" dt="2026-01-17T11:53:39.712"/>
-  </p1510:revLst>
-</p1510:revInfo>
-</file>
-
 <file path=ppt/changesInfos/changesInfo1.xml><?xml version="1.0" encoding="utf-8"?>
 <pc:chgInfo xmlns:a="http://schemas.openxmlformats.org/drawingml/2006/main" xmlns:r="http://schemas.openxmlformats.org/officeDocument/2006/relationships" xmlns:ac="http://schemas.microsoft.com/office/drawing/2013/main/command" xmlns:pc="http://schemas.microsoft.com/office/powerpoint/2013/main/command">
   <pc:docChgLst>
     <pc:chgData name="Nicolas Bogalheiro" userId="dc4f69c44af47b0d" providerId="LiveId" clId="{10551B59-746F-4326-8996-D05D4F5D8789}"/>
     <pc:docChg chg="undo redo custSel addSld delSld modSld sldOrd">
-      <pc:chgData name="Nicolas Bogalheiro" userId="dc4f69c44af47b0d" providerId="LiveId" clId="{10551B59-746F-4326-8996-D05D4F5D8789}" dt="2026-01-17T12:00:30.616" v="4145" actId="20577"/>
+      <pc:chgData name="Nicolas Bogalheiro" userId="dc4f69c44af47b0d" providerId="LiveId" clId="{10551B59-746F-4326-8996-D05D4F5D8789}" dt="2026-09-24T16:19:02.560" v="4163" actId="14100"/>
       <pc:docMkLst>
         <pc:docMk/>
       </pc:docMkLst>
-      <pc:sldChg chg="addSp delSp modSp mod setBg">
-        <pc:chgData name="Nicolas Bogalheiro" userId="dc4f69c44af47b0d" providerId="LiveId" clId="{10551B59-746F-4326-8996-D05D4F5D8789}" dt="2026-01-06T19:45:04.764" v="1859" actId="478"/>
-        <pc:sldMkLst>
-          <pc:docMk/>
-          <pc:sldMk cId="0" sldId="256"/>
-        </pc:sldMkLst>
-        <pc:picChg chg="add mod">
-          <ac:chgData name="Nicolas Bogalheiro" userId="dc4f69c44af47b0d" providerId="LiveId" clId="{10551B59-746F-4326-8996-D05D4F5D8789}" dt="2026-01-05T21:12:51.640" v="147" actId="27614"/>
-          <ac:picMkLst>
-            <pc:docMk/>
-            <pc:sldMk cId="0" sldId="256"/>
-            <ac:picMk id="5" creationId="{814A1110-3C76-95BE-E64D-D87B9428ADA6}"/>
-          </ac:picMkLst>
-        </pc:picChg>
-      </pc:sldChg>
-      <pc:sldChg chg="modSp add mod">
-        <pc:chgData name="Nicolas Bogalheiro" userId="dc4f69c44af47b0d" providerId="LiveId" clId="{10551B59-746F-4326-8996-D05D4F5D8789}" dt="2026-01-06T20:35:02.116" v="2945" actId="790"/>
-        <pc:sldMkLst>
-          <pc:docMk/>
-          <pc:sldMk cId="2438486368" sldId="258"/>
-        </pc:sldMkLst>
-        <pc:spChg chg="mod">
-          <ac:chgData name="Nicolas Bogalheiro" userId="dc4f69c44af47b0d" providerId="LiveId" clId="{10551B59-746F-4326-8996-D05D4F5D8789}" dt="2026-01-06T20:33:23.807" v="2940" actId="20577"/>
-          <ac:spMkLst>
-            <pc:docMk/>
-            <pc:sldMk cId="2438486368" sldId="258"/>
-            <ac:spMk id="3" creationId="{00000000-0000-0000-0000-000000000000}"/>
-          </ac:spMkLst>
-        </pc:spChg>
-        <pc:spChg chg="mod">
-          <ac:chgData name="Nicolas Bogalheiro" userId="dc4f69c44af47b0d" providerId="LiveId" clId="{10551B59-746F-4326-8996-D05D4F5D8789}" dt="2026-01-06T20:35:02.116" v="2945" actId="790"/>
-          <ac:spMkLst>
-            <pc:docMk/>
-            <pc:sldMk cId="2438486368" sldId="258"/>
-            <ac:spMk id="4" creationId="{00000000-0000-0000-0000-000000000000}"/>
-          </ac:spMkLst>
-        </pc:spChg>
-      </pc:sldChg>
-      <pc:sldChg chg="delSp modSp mod">
-        <pc:chgData name="Nicolas Bogalheiro" userId="dc4f69c44af47b0d" providerId="LiveId" clId="{10551B59-746F-4326-8996-D05D4F5D8789}" dt="2026-01-06T20:28:55.294" v="2770" actId="20577"/>
-        <pc:sldMkLst>
-          <pc:docMk/>
-          <pc:sldMk cId="0" sldId="259"/>
-        </pc:sldMkLst>
-        <pc:spChg chg="mod">
-          <ac:chgData name="Nicolas Bogalheiro" userId="dc4f69c44af47b0d" providerId="LiveId" clId="{10551B59-746F-4326-8996-D05D4F5D8789}" dt="2026-01-06T20:28:55.294" v="2770" actId="20577"/>
-          <ac:spMkLst>
-            <pc:docMk/>
-            <pc:sldMk cId="0" sldId="259"/>
-            <ac:spMk id="3" creationId="{00000000-0000-0000-0000-000000000000}"/>
-          </ac:spMkLst>
-        </pc:spChg>
-        <pc:spChg chg="mod">
-          <ac:chgData name="Nicolas Bogalheiro" userId="dc4f69c44af47b0d" providerId="LiveId" clId="{10551B59-746F-4326-8996-D05D4F5D8789}" dt="2026-01-05T22:13:16.776" v="1727" actId="12"/>
-          <ac:spMkLst>
-            <pc:docMk/>
-            <pc:sldMk cId="0" sldId="259"/>
-            <ac:spMk id="4" creationId="{00000000-0000-0000-0000-000000000000}"/>
-          </ac:spMkLst>
-        </pc:spChg>
-      </pc:sldChg>
-      <pc:sldChg chg="delSp modSp mod">
-        <pc:chgData name="Nicolas Bogalheiro" userId="dc4f69c44af47b0d" providerId="LiveId" clId="{10551B59-746F-4326-8996-D05D4F5D8789}" dt="2026-01-06T20:29:00.518" v="2773" actId="20577"/>
-        <pc:sldMkLst>
-          <pc:docMk/>
-          <pc:sldMk cId="0" sldId="260"/>
-        </pc:sldMkLst>
-        <pc:spChg chg="mod">
-          <ac:chgData name="Nicolas Bogalheiro" userId="dc4f69c44af47b0d" providerId="LiveId" clId="{10551B59-746F-4326-8996-D05D4F5D8789}" dt="2026-01-06T20:29:00.518" v="2773" actId="20577"/>
-          <ac:spMkLst>
-            <pc:docMk/>
-            <pc:sldMk cId="0" sldId="260"/>
-            <ac:spMk id="3" creationId="{00000000-0000-0000-0000-000000000000}"/>
-          </ac:spMkLst>
-        </pc:spChg>
-        <pc:spChg chg="mod">
-          <ac:chgData name="Nicolas Bogalheiro" userId="dc4f69c44af47b0d" providerId="LiveId" clId="{10551B59-746F-4326-8996-D05D4F5D8789}" dt="2026-01-05T22:13:28.106" v="1729" actId="12"/>
-          <ac:spMkLst>
-            <pc:docMk/>
-            <pc:sldMk cId="0" sldId="260"/>
-            <ac:spMk id="4" creationId="{00000000-0000-0000-0000-000000000000}"/>
-          </ac:spMkLst>
-        </pc:spChg>
-      </pc:sldChg>
-      <pc:sldChg chg="delSp modSp mod">
-        <pc:chgData name="Nicolas Bogalheiro" userId="dc4f69c44af47b0d" providerId="LiveId" clId="{10551B59-746F-4326-8996-D05D4F5D8789}" dt="2026-01-06T20:34:51.934" v="2944" actId="20577"/>
-        <pc:sldMkLst>
-          <pc:docMk/>
-          <pc:sldMk cId="0" sldId="261"/>
-        </pc:sldMkLst>
-        <pc:spChg chg="mod">
-          <ac:chgData name="Nicolas Bogalheiro" userId="dc4f69c44af47b0d" providerId="LiveId" clId="{10551B59-746F-4326-8996-D05D4F5D8789}" dt="2026-01-06T20:34:51.934" v="2944" actId="20577"/>
-          <ac:spMkLst>
-            <pc:docMk/>
-            <pc:sldMk cId="0" sldId="261"/>
-            <ac:spMk id="3" creationId="{00000000-0000-0000-0000-000000000000}"/>
-          </ac:spMkLst>
-        </pc:spChg>
-        <pc:spChg chg="mod">
-          <ac:chgData name="Nicolas Bogalheiro" userId="dc4f69c44af47b0d" providerId="LiveId" clId="{10551B59-746F-4326-8996-D05D4F5D8789}" dt="2026-01-05T22:14:25.119" v="1752" actId="12"/>
-          <ac:spMkLst>
-            <pc:docMk/>
-            <pc:sldMk cId="0" sldId="261"/>
-            <ac:spMk id="4" creationId="{00000000-0000-0000-0000-000000000000}"/>
-          </ac:spMkLst>
-        </pc:spChg>
-      </pc:sldChg>
-      <pc:sldChg chg="delSp modSp mod ord">
-        <pc:chgData name="Nicolas Bogalheiro" userId="dc4f69c44af47b0d" providerId="LiveId" clId="{10551B59-746F-4326-8996-D05D4F5D8789}" dt="2026-01-06T20:29:46.187" v="2805" actId="20577"/>
-        <pc:sldMkLst>
-          <pc:docMk/>
-          <pc:sldMk cId="0" sldId="262"/>
-        </pc:sldMkLst>
-        <pc:spChg chg="mod">
-          <ac:chgData name="Nicolas Bogalheiro" userId="dc4f69c44af47b0d" providerId="LiveId" clId="{10551B59-746F-4326-8996-D05D4F5D8789}" dt="2026-01-06T20:29:46.187" v="2805" actId="20577"/>
-          <ac:spMkLst>
-            <pc:docMk/>
-            <pc:sldMk cId="0" sldId="262"/>
-            <ac:spMk id="3" creationId="{00000000-0000-0000-0000-000000000000}"/>
-          </ac:spMkLst>
-        </pc:spChg>
-        <pc:spChg chg="mod">
-          <ac:chgData name="Nicolas Bogalheiro" userId="dc4f69c44af47b0d" providerId="LiveId" clId="{10551B59-746F-4326-8996-D05D4F5D8789}" dt="2026-01-05T22:14:32.218" v="1753" actId="12"/>
-          <ac:spMkLst>
-            <pc:docMk/>
-            <pc:sldMk cId="0" sldId="262"/>
-            <ac:spMk id="4" creationId="{00000000-0000-0000-0000-000000000000}"/>
-          </ac:spMkLst>
-        </pc:spChg>
-      </pc:sldChg>
-      <pc:sldChg chg="delSp modSp mod">
-        <pc:chgData name="Nicolas Bogalheiro" userId="dc4f69c44af47b0d" providerId="LiveId" clId="{10551B59-746F-4326-8996-D05D4F5D8789}" dt="2026-01-06T20:34:42.537" v="2943" actId="20577"/>
-        <pc:sldMkLst>
-          <pc:docMk/>
-          <pc:sldMk cId="0" sldId="263"/>
-        </pc:sldMkLst>
-        <pc:spChg chg="mod">
-          <ac:chgData name="Nicolas Bogalheiro" userId="dc4f69c44af47b0d" providerId="LiveId" clId="{10551B59-746F-4326-8996-D05D4F5D8789}" dt="2026-01-06T20:34:42.537" v="2943" actId="20577"/>
-          <ac:spMkLst>
-            <pc:docMk/>
-            <pc:sldMk cId="0" sldId="263"/>
-            <ac:spMk id="3" creationId="{00000000-0000-0000-0000-000000000000}"/>
-          </ac:spMkLst>
-        </pc:spChg>
-        <pc:spChg chg="mod">
-          <ac:chgData name="Nicolas Bogalheiro" userId="dc4f69c44af47b0d" providerId="LiveId" clId="{10551B59-746F-4326-8996-D05D4F5D8789}" dt="2026-01-05T22:14:45.654" v="1754" actId="12"/>
-          <ac:spMkLst>
-            <pc:docMk/>
-            <pc:sldMk cId="0" sldId="263"/>
-            <ac:spMk id="4" creationId="{00000000-0000-0000-0000-000000000000}"/>
-          </ac:spMkLst>
-        </pc:spChg>
-      </pc:sldChg>
-      <pc:sldChg chg="delSp modSp mod">
-        <pc:chgData name="Nicolas Bogalheiro" userId="dc4f69c44af47b0d" providerId="LiveId" clId="{10551B59-746F-4326-8996-D05D4F5D8789}" dt="2026-01-17T11:59:59.127" v="4134" actId="207"/>
-        <pc:sldMkLst>
-          <pc:docMk/>
-          <pc:sldMk cId="0" sldId="264"/>
-        </pc:sldMkLst>
-        <pc:spChg chg="mod">
-          <ac:chgData name="Nicolas Bogalheiro" userId="dc4f69c44af47b0d" providerId="LiveId" clId="{10551B59-746F-4326-8996-D05D4F5D8789}" dt="2026-01-06T20:38:24.103" v="3001" actId="20577"/>
-          <ac:spMkLst>
-            <pc:docMk/>
-            <pc:sldMk cId="0" sldId="264"/>
-            <ac:spMk id="3" creationId="{00000000-0000-0000-0000-000000000000}"/>
-          </ac:spMkLst>
-        </pc:spChg>
-        <pc:spChg chg="mod">
-          <ac:chgData name="Nicolas Bogalheiro" userId="dc4f69c44af47b0d" providerId="LiveId" clId="{10551B59-746F-4326-8996-D05D4F5D8789}" dt="2026-01-17T11:59:59.127" v="4134" actId="207"/>
-          <ac:spMkLst>
-            <pc:docMk/>
-            <pc:sldMk cId="0" sldId="264"/>
-            <ac:spMk id="4" creationId="{00000000-0000-0000-0000-000000000000}"/>
-          </ac:spMkLst>
-        </pc:spChg>
-      </pc:sldChg>
-      <pc:sldChg chg="delSp modSp mod ord">
-        <pc:chgData name="Nicolas Bogalheiro" userId="dc4f69c44af47b0d" providerId="LiveId" clId="{10551B59-746F-4326-8996-D05D4F5D8789}" dt="2026-01-06T20:22:52.328" v="2503" actId="20577"/>
-        <pc:sldMkLst>
-          <pc:docMk/>
-          <pc:sldMk cId="0" sldId="265"/>
-        </pc:sldMkLst>
-        <pc:spChg chg="mod">
-          <ac:chgData name="Nicolas Bogalheiro" userId="dc4f69c44af47b0d" providerId="LiveId" clId="{10551B59-746F-4326-8996-D05D4F5D8789}" dt="2026-01-05T21:38:42.384" v="1003" actId="20577"/>
-          <ac:spMkLst>
-            <pc:docMk/>
-            <pc:sldMk cId="0" sldId="265"/>
-            <ac:spMk id="3" creationId="{00000000-0000-0000-0000-000000000000}"/>
-          </ac:spMkLst>
-        </pc:spChg>
-        <pc:spChg chg="mod">
-          <ac:chgData name="Nicolas Bogalheiro" userId="dc4f69c44af47b0d" providerId="LiveId" clId="{10551B59-746F-4326-8996-D05D4F5D8789}" dt="2026-01-06T20:22:52.328" v="2503" actId="20577"/>
-          <ac:spMkLst>
-            <pc:docMk/>
-            <pc:sldMk cId="0" sldId="265"/>
-            <ac:spMk id="4" creationId="{00000000-0000-0000-0000-000000000000}"/>
-          </ac:spMkLst>
-        </pc:spChg>
-      </pc:sldChg>
-      <pc:sldChg chg="addSp modSp add mod modTransition modAnim">
-        <pc:chgData name="Nicolas Bogalheiro" userId="dc4f69c44af47b0d" providerId="LiveId" clId="{10551B59-746F-4326-8996-D05D4F5D8789}" dt="2026-01-17T11:53:39.712" v="3847" actId="20577"/>
-        <pc:sldMkLst>
-          <pc:docMk/>
-          <pc:sldMk cId="1210646930" sldId="266"/>
-        </pc:sldMkLst>
-        <pc:spChg chg="add mod ord">
-          <ac:chgData name="Nicolas Bogalheiro" userId="dc4f69c44af47b0d" providerId="LiveId" clId="{10551B59-746F-4326-8996-D05D4F5D8789}" dt="2026-01-17T11:53:39.712" v="3847" actId="20577"/>
-          <ac:spMkLst>
-            <pc:docMk/>
-            <pc:sldMk cId="1210646930" sldId="266"/>
-            <ac:spMk id="2" creationId="{C6E26627-DA86-23D4-BC68-32F283B36B7B}"/>
-          </ac:spMkLst>
-        </pc:spChg>
-        <pc:spChg chg="mod">
-          <ac:chgData name="Nicolas Bogalheiro" userId="dc4f69c44af47b0d" providerId="LiveId" clId="{10551B59-746F-4326-8996-D05D4F5D8789}" dt="2026-01-05T21:19:08.877" v="382" actId="20577"/>
-          <ac:spMkLst>
-            <pc:docMk/>
-            <pc:sldMk cId="1210646930" sldId="266"/>
-            <ac:spMk id="3" creationId="{93BF5DF0-0109-C4D6-E727-F7B9658FDCB1}"/>
-          </ac:spMkLst>
-        </pc:spChg>
-        <pc:spChg chg="mod">
-          <ac:chgData name="Nicolas Bogalheiro" userId="dc4f69c44af47b0d" providerId="LiveId" clId="{10551B59-746F-4326-8996-D05D4F5D8789}" dt="2026-01-06T20:58:13.983" v="3188" actId="2"/>
-          <ac:spMkLst>
-            <pc:docMk/>
-            <pc:sldMk cId="1210646930" sldId="266"/>
-            <ac:spMk id="4" creationId="{A0D7C494-CB83-5DCB-73EA-5F58912FA2A5}"/>
-          </ac:spMkLst>
-        </pc:spChg>
-      </pc:sldChg>
       <pc:sldChg chg="addSp delSp modSp add mod">
-        <pc:chgData name="Nicolas Bogalheiro" userId="dc4f69c44af47b0d" providerId="LiveId" clId="{10551B59-746F-4326-8996-D05D4F5D8789}" dt="2026-01-17T12:00:30.616" v="4145" actId="20577"/>
-        <pc:sldMkLst>
-          <pc:docMk/>
-          <pc:sldMk cId="414777145" sldId="268"/>
-        </pc:sldMkLst>
-        <pc:spChg chg="mod">
-          <ac:chgData name="Nicolas Bogalheiro" userId="dc4f69c44af47b0d" providerId="LiveId" clId="{10551B59-746F-4326-8996-D05D4F5D8789}" dt="2026-01-17T12:00:25.673" v="4137" actId="20577"/>
-          <ac:spMkLst>
-            <pc:docMk/>
-            <pc:sldMk cId="414777145" sldId="268"/>
-            <ac:spMk id="3" creationId="{DDC5C6FE-D626-5897-D1B0-F1F4A976750E}"/>
-          </ac:spMkLst>
-        </pc:spChg>
-        <pc:spChg chg="mod">
-          <ac:chgData name="Nicolas Bogalheiro" userId="dc4f69c44af47b0d" providerId="LiveId" clId="{10551B59-746F-4326-8996-D05D4F5D8789}" dt="2026-01-17T12:00:30.616" v="4145" actId="20577"/>
-          <ac:spMkLst>
-            <pc:docMk/>
-            <pc:sldMk cId="414777145" sldId="268"/>
-            <ac:spMk id="4" creationId="{28D46B3C-065D-2AAD-5E08-536EA7944997}"/>
-          </ac:spMkLst>
-        </pc:spChg>
-        <pc:picChg chg="add mod">
-          <ac:chgData name="Nicolas Bogalheiro" userId="dc4f69c44af47b0d" providerId="LiveId" clId="{10551B59-746F-4326-8996-D05D4F5D8789}" dt="2026-01-06T20:55:00.983" v="3160" actId="14100"/>
-          <ac:picMkLst>
-            <pc:docMk/>
-            <pc:sldMk cId="414777145" sldId="268"/>
-            <ac:picMk id="5" creationId="{8AE34B47-950A-0CF2-BAEE-A28FB0481032}"/>
-          </ac:picMkLst>
-        </pc:picChg>
-      </pc:sldChg>
-      <pc:sldChg chg="addSp delSp modSp add mod">
-        <pc:chgData name="Nicolas Bogalheiro" userId="dc4f69c44af47b0d" providerId="LiveId" clId="{10551B59-746F-4326-8996-D05D4F5D8789}" dt="2026-01-17T11:53:08.050" v="3837"/>
-        <pc:sldMkLst>
-          <pc:docMk/>
-          <pc:sldMk cId="3853632487" sldId="269"/>
-        </pc:sldMkLst>
-        <pc:spChg chg="mod">
-          <ac:chgData name="Nicolas Bogalheiro" userId="dc4f69c44af47b0d" providerId="LiveId" clId="{10551B59-746F-4326-8996-D05D4F5D8789}" dt="2026-01-06T20:26:43.344" v="2576" actId="20577"/>
-          <ac:spMkLst>
-            <pc:docMk/>
-            <pc:sldMk cId="3853632487" sldId="269"/>
-            <ac:spMk id="3" creationId="{576B20AD-C739-929D-C6B4-FAD4A886A3EA}"/>
-          </ac:spMkLst>
-        </pc:spChg>
-        <pc:spChg chg="add mod">
-          <ac:chgData name="Nicolas Bogalheiro" userId="dc4f69c44af47b0d" providerId="LiveId" clId="{10551B59-746F-4326-8996-D05D4F5D8789}" dt="2026-01-17T11:53:08.050" v="3837"/>
-          <ac:spMkLst>
-            <pc:docMk/>
-            <pc:sldMk cId="3853632487" sldId="269"/>
-            <ac:spMk id="5" creationId="{FA9D77A5-61FF-8F80-DFBF-9AC7170CAC0C}"/>
-          </ac:spMkLst>
-        </pc:spChg>
-      </pc:sldChg>
-      <pc:sldChg chg="addSp delSp modSp add mod">
-        <pc:chgData name="Nicolas Bogalheiro" userId="dc4f69c44af47b0d" providerId="LiveId" clId="{10551B59-746F-4326-8996-D05D4F5D8789}" dt="2026-01-17T11:53:20.262" v="3839"/>
-        <pc:sldMkLst>
-          <pc:docMk/>
-          <pc:sldMk cId="310682677" sldId="270"/>
-        </pc:sldMkLst>
-        <pc:spChg chg="add mod">
-          <ac:chgData name="Nicolas Bogalheiro" userId="dc4f69c44af47b0d" providerId="LiveId" clId="{10551B59-746F-4326-8996-D05D4F5D8789}" dt="2026-01-17T11:53:20.262" v="3839"/>
-          <ac:spMkLst>
-            <pc:docMk/>
-            <pc:sldMk cId="310682677" sldId="270"/>
-            <ac:spMk id="2" creationId="{1F504F01-1E8E-1BF5-7627-046A76484ECB}"/>
-          </ac:spMkLst>
-        </pc:spChg>
-        <pc:spChg chg="mod">
-          <ac:chgData name="Nicolas Bogalheiro" userId="dc4f69c44af47b0d" providerId="LiveId" clId="{10551B59-746F-4326-8996-D05D4F5D8789}" dt="2026-01-06T20:38:06.135" v="2999" actId="790"/>
-          <ac:spMkLst>
-            <pc:docMk/>
-            <pc:sldMk cId="310682677" sldId="270"/>
-            <ac:spMk id="3" creationId="{AA54D1AB-14F9-5D82-FF55-80640BEF74BD}"/>
-          </ac:spMkLst>
-        </pc:spChg>
-      </pc:sldChg>
-      <pc:sldChg chg="modSp add mod">
-        <pc:chgData name="Nicolas Bogalheiro" userId="dc4f69c44af47b0d" providerId="LiveId" clId="{10551B59-746F-4326-8996-D05D4F5D8789}" dt="2026-01-17T11:53:00.680" v="3836" actId="5793"/>
-        <pc:sldMkLst>
-          <pc:docMk/>
-          <pc:sldMk cId="2272530269" sldId="271"/>
-        </pc:sldMkLst>
-        <pc:spChg chg="mod">
-          <ac:chgData name="Nicolas Bogalheiro" userId="dc4f69c44af47b0d" providerId="LiveId" clId="{10551B59-746F-4326-8996-D05D4F5D8789}" dt="2026-01-17T11:53:00.680" v="3836" actId="5793"/>
-          <ac:spMkLst>
-            <pc:docMk/>
-            <pc:sldMk cId="2272530269" sldId="271"/>
-            <ac:spMk id="2" creationId="{1B7CEE41-2A69-B643-E8F9-ECFF57681C15}"/>
-          </ac:spMkLst>
-        </pc:spChg>
-        <pc:spChg chg="mod">
-          <ac:chgData name="Nicolas Bogalheiro" userId="dc4f69c44af47b0d" providerId="LiveId" clId="{10551B59-746F-4326-8996-D05D4F5D8789}" dt="2026-01-06T20:27:29.610" v="2636" actId="20577"/>
-          <ac:spMkLst>
-            <pc:docMk/>
-            <pc:sldMk cId="2272530269" sldId="271"/>
-            <ac:spMk id="3" creationId="{518E587F-87E0-7185-4C1B-997DDCFF86AC}"/>
-          </ac:spMkLst>
-        </pc:spChg>
-      </pc:sldChg>
-      <pc:sldChg chg="addSp delSp modSp add mod">
-        <pc:chgData name="Nicolas Bogalheiro" userId="dc4f69c44af47b0d" providerId="LiveId" clId="{10551B59-746F-4326-8996-D05D4F5D8789}" dt="2026-01-06T21:09:51.734" v="3199" actId="1076"/>
+        <pc:chgData name="Nicolas Bogalheiro" userId="dc4f69c44af47b0d" providerId="LiveId" clId="{10551B59-746F-4326-8996-D05D4F5D8789}" dt="2026-09-24T16:19:02.560" v="4163" actId="14100"/>
         <pc:sldMkLst>
           <pc:docMk/>
           <pc:sldMk cId="1548898421" sldId="272"/>
         </pc:sldMkLst>
-        <pc:spChg chg="add mod">
-          <ac:chgData name="Nicolas Bogalheiro" userId="dc4f69c44af47b0d" providerId="LiveId" clId="{10551B59-746F-4326-8996-D05D4F5D8789}" dt="2026-01-06T20:37:15.579" v="2995" actId="1076"/>
-          <ac:spMkLst>
-            <pc:docMk/>
-            <pc:sldMk cId="1548898421" sldId="272"/>
-            <ac:spMk id="6" creationId="{434FE292-0690-D267-3D05-58DDFE6D3AE6}"/>
-          </ac:spMkLst>
-        </pc:spChg>
-        <pc:picChg chg="add mod">
-          <ac:chgData name="Nicolas Bogalheiro" userId="dc4f69c44af47b0d" providerId="LiveId" clId="{10551B59-746F-4326-8996-D05D4F5D8789}" dt="2026-01-06T21:09:51.734" v="3199" actId="1076"/>
+        <pc:picChg chg="add del mod">
+          <ac:chgData name="Nicolas Bogalheiro" userId="dc4f69c44af47b0d" providerId="LiveId" clId="{10551B59-746F-4326-8996-D05D4F5D8789}" dt="2026-09-24T16:18:38.960" v="4151" actId="478"/>
           <ac:picMkLst>
             <pc:docMk/>
             <pc:sldMk cId="1548898421" sldId="272"/>
             <ac:picMk id="3" creationId="{6EC9212E-C58E-A184-1612-E18F90C8233F}"/>
           </ac:picMkLst>
         </pc:picChg>
-        <pc:picChg chg="add mod ord">
-          <ac:chgData name="Nicolas Bogalheiro" userId="dc4f69c44af47b0d" providerId="LiveId" clId="{10551B59-746F-4326-8996-D05D4F5D8789}" dt="2026-01-06T21:08:25.899" v="3197" actId="1076"/>
+        <pc:picChg chg="add del mod">
+          <ac:chgData name="Nicolas Bogalheiro" userId="dc4f69c44af47b0d" providerId="LiveId" clId="{10551B59-746F-4326-8996-D05D4F5D8789}" dt="2026-09-24T16:18:40.987" v="4152" actId="478"/>
           <ac:picMkLst>
             <pc:docMk/>
             <pc:sldMk cId="1548898421" sldId="272"/>
-            <ac:picMk id="5" creationId="{C9EB7EE4-7C8E-58DD-4978-0897ADB4B103}"/>
+            <ac:picMk id="4" creationId="{46488A77-EEE0-4C0D-48AD-5E2C3DC22844}"/>
+          </ac:picMkLst>
+        </pc:picChg>
+        <pc:picChg chg="add del mod">
+          <ac:chgData name="Nicolas Bogalheiro" userId="dc4f69c44af47b0d" providerId="LiveId" clId="{10551B59-746F-4326-8996-D05D4F5D8789}" dt="2026-09-24T16:18:53.786" v="4153" actId="478"/>
+          <ac:picMkLst>
+            <pc:docMk/>
+            <pc:sldMk cId="1548898421" sldId="272"/>
+            <ac:picMk id="8" creationId="{F88F921E-F3F7-2CF5-9429-837A0832FB85}"/>
+          </ac:picMkLst>
+        </pc:picChg>
+        <pc:picChg chg="add mod">
+          <ac:chgData name="Nicolas Bogalheiro" userId="dc4f69c44af47b0d" providerId="LiveId" clId="{10551B59-746F-4326-8996-D05D4F5D8789}" dt="2026-09-24T16:19:02.560" v="4163" actId="14100"/>
+          <ac:picMkLst>
+            <pc:docMk/>
+            <pc:sldMk cId="1548898421" sldId="272"/>
+            <ac:picMk id="10" creationId="{748802DF-E105-23CB-4BD1-43FC2631566E}"/>
+          </ac:picMkLst>
+        </pc:picChg>
+        <pc:picChg chg="add mod">
+          <ac:chgData name="Nicolas Bogalheiro" userId="dc4f69c44af47b0d" providerId="LiveId" clId="{10551B59-746F-4326-8996-D05D4F5D8789}" dt="2026-09-24T16:18:58.580" v="4161" actId="1076"/>
+          <ac:picMkLst>
+            <pc:docMk/>
+            <pc:sldMk cId="1548898421" sldId="272"/>
+            <ac:picMk id="12" creationId="{25C6B0E1-D988-CC51-FA07-CB2A3A8A5DB4}"/>
           </ac:picMkLst>
         </pc:picChg>
       </pc:sldChg>
@@ -699,7 +377,7 @@
           <a:p>
             <a:fld id="{5BCAD085-E8A6-8845-BD4E-CB4CCA059FC4}" type="datetimeFigureOut">
               <a:rPr lang="en-US" smtClean="0"/>
-              <a:t>2/21/2026</a:t>
+              <a:t>9/24/2026</a:t>
             </a:fld>
             <a:endParaRPr lang="en-US" dirty="0"/>
           </a:p>
@@ -867,7 +545,7 @@
           <a:p>
             <a:fld id="{5BCAD085-E8A6-8845-BD4E-CB4CCA059FC4}" type="datetimeFigureOut">
               <a:rPr lang="en-US" smtClean="0"/>
-              <a:t>2/21/2026</a:t>
+              <a:t>9/24/2026</a:t>
             </a:fld>
             <a:endParaRPr lang="en-US" dirty="0"/>
           </a:p>
@@ -1045,7 +723,7 @@
           <a:p>
             <a:fld id="{5BCAD085-E8A6-8845-BD4E-CB4CCA059FC4}" type="datetimeFigureOut">
               <a:rPr lang="en-US" smtClean="0"/>
-              <a:t>2/21/2026</a:t>
+              <a:t>9/24/2026</a:t>
             </a:fld>
             <a:endParaRPr lang="en-US" dirty="0"/>
           </a:p>
@@ -1213,7 +891,7 @@
           <a:p>
             <a:fld id="{5BCAD085-E8A6-8845-BD4E-CB4CCA059FC4}" type="datetimeFigureOut">
               <a:rPr lang="en-US" smtClean="0"/>
-              <a:t>2/21/2026</a:t>
+              <a:t>9/24/2026</a:t>
             </a:fld>
             <a:endParaRPr lang="en-US" dirty="0"/>
           </a:p>
@@ -1458,7 +1136,7 @@
           <a:p>
             <a:fld id="{5BCAD085-E8A6-8845-BD4E-CB4CCA059FC4}" type="datetimeFigureOut">
               <a:rPr lang="en-US" smtClean="0"/>
-              <a:t>2/21/2026</a:t>
+              <a:t>9/24/2026</a:t>
             </a:fld>
             <a:endParaRPr lang="en-US" dirty="0"/>
           </a:p>
@@ -1743,7 +1421,7 @@
           <a:p>
             <a:fld id="{5BCAD085-E8A6-8845-BD4E-CB4CCA059FC4}" type="datetimeFigureOut">
               <a:rPr lang="en-US" smtClean="0"/>
-              <a:t>2/21/2026</a:t>
+              <a:t>9/24/2026</a:t>
             </a:fld>
             <a:endParaRPr lang="en-US" dirty="0"/>
           </a:p>
@@ -2162,7 +1840,7 @@
           <a:p>
             <a:fld id="{5BCAD085-E8A6-8845-BD4E-CB4CCA059FC4}" type="datetimeFigureOut">
               <a:rPr lang="en-US" smtClean="0"/>
-              <a:t>2/21/2026</a:t>
+              <a:t>9/24/2026</a:t>
             </a:fld>
             <a:endParaRPr lang="en-US" dirty="0"/>
           </a:p>
@@ -2279,7 +1957,7 @@
           <a:p>
             <a:fld id="{5BCAD085-E8A6-8845-BD4E-CB4CCA059FC4}" type="datetimeFigureOut">
               <a:rPr lang="en-US" smtClean="0"/>
-              <a:t>2/21/2026</a:t>
+              <a:t>9/24/2026</a:t>
             </a:fld>
             <a:endParaRPr lang="en-US" dirty="0"/>
           </a:p>
@@ -2374,7 +2052,7 @@
           <a:p>
             <a:fld id="{5BCAD085-E8A6-8845-BD4E-CB4CCA059FC4}" type="datetimeFigureOut">
               <a:rPr lang="en-US" smtClean="0"/>
-              <a:t>2/21/2026</a:t>
+              <a:t>9/24/2026</a:t>
             </a:fld>
             <a:endParaRPr lang="en-US" dirty="0"/>
           </a:p>
@@ -2649,7 +2327,7 @@
           <a:p>
             <a:fld id="{5BCAD085-E8A6-8845-BD4E-CB4CCA059FC4}" type="datetimeFigureOut">
               <a:rPr lang="en-US" smtClean="0"/>
-              <a:t>2/21/2026</a:t>
+              <a:t>9/24/2026</a:t>
             </a:fld>
             <a:endParaRPr lang="en-US" dirty="0"/>
           </a:p>
@@ -2901,7 +2579,7 @@
           <a:p>
             <a:fld id="{5BCAD085-E8A6-8845-BD4E-CB4CCA059FC4}" type="datetimeFigureOut">
               <a:rPr lang="en-US" smtClean="0"/>
-              <a:t>2/21/2026</a:t>
+              <a:t>9/24/2026</a:t>
             </a:fld>
             <a:endParaRPr lang="en-US" dirty="0"/>
           </a:p>
@@ -3112,7 +2790,7 @@
           <a:p>
             <a:fld id="{5BCAD085-E8A6-8845-BD4E-CB4CCA059FC4}" type="datetimeFigureOut">
               <a:rPr lang="en-US" smtClean="0"/>
-              <a:t>2/21/2026</a:t>
+              <a:t>9/24/2026</a:t>
             </a:fld>
             <a:endParaRPr lang="en-US" dirty="0"/>
           </a:p>
@@ -4433,10 +4111,10 @@
       </p:pic>
       <p:pic>
         <p:nvPicPr>
-          <p:cNvPr id="3" name="Image 2" descr="Une image contenant motif, carré, Rectangle, pixel&#10;&#10;Le contenu généré par l’IA peut être incorrect.">
+          <p:cNvPr id="10" name="Image 9">
             <a:extLst>
               <a:ext uri="{FF2B5EF4-FFF2-40B4-BE49-F238E27FC236}">
-                <a16:creationId xmlns:a16="http://schemas.microsoft.com/office/drawing/2014/main" id="{6EC9212E-C58E-A184-1612-E18F90C8233F}"/>
+                <a16:creationId xmlns:a16="http://schemas.microsoft.com/office/drawing/2014/main" id="{748802DF-E105-23CB-4BD1-43FC2631566E}"/>
               </a:ext>
             </a:extLst>
           </p:cNvPr>
@@ -4453,8 +4131,38 @@
         </p:blipFill>
         <p:spPr>
           <a:xfrm>
-            <a:off x="6991960" y="2814483"/>
-            <a:ext cx="1236837" cy="1229034"/>
+            <a:off x="7396316" y="3735029"/>
+            <a:ext cx="1383890" cy="1383890"/>
+          </a:xfrm>
+          <a:prstGeom prst="rect">
+            <a:avLst/>
+          </a:prstGeom>
+        </p:spPr>
+      </p:pic>
+      <p:pic>
+        <p:nvPicPr>
+          <p:cNvPr id="12" name="Image 11">
+            <a:extLst>
+              <a:ext uri="{FF2B5EF4-FFF2-40B4-BE49-F238E27FC236}">
+                <a16:creationId xmlns:a16="http://schemas.microsoft.com/office/drawing/2014/main" id="{25C6B0E1-D988-CC51-FA07-CB2A3A8A5DB4}"/>
+              </a:ext>
+            </a:extLst>
+          </p:cNvPr>
+          <p:cNvPicPr>
+            <a:picLocks noChangeAspect="1"/>
+          </p:cNvPicPr>
+          <p:nvPr/>
+        </p:nvPicPr>
+        <p:blipFill>
+          <a:blip r:embed="rId5"/>
+          <a:stretch>
+            <a:fillRect/>
+          </a:stretch>
+        </p:blipFill>
+        <p:spPr>
+          <a:xfrm>
+            <a:off x="7396316" y="2055557"/>
+            <a:ext cx="1383890" cy="1383890"/>
           </a:xfrm>
           <a:prstGeom prst="rect">
             <a:avLst/>

</xml_diff>